<commit_message>
Add new scripts and notebooks for 3D functional analysis
- Created 'run_lengthmap3D.py' for 3D simulation of neuronal networks, including functions for network creation, dynamics, and GNA computation.
- Added 'functional_analysis.ipynb' and 'functional_analysis copy.ipynb' for data analysis and visualization of simulation results.
- Implemented chunk processing for axonal lengths and base sigmas to facilitate parallel execution.
- Included detailed logging of simulation parameters and results for better traceability.
</commit_message>
<xml_diff>
--- a/Presentación1.pptx
+++ b/Presentación1.pptx
@@ -259,7 +259,7 @@
           <a:p>
             <a:fld id="{1A8F9070-8861-4FBE-84D2-FE8E101678E2}" type="datetimeFigureOut">
               <a:rPr lang="es-ES" smtClean="0"/>
-              <a:t>10/06/2026</a:t>
+              <a:t>14/06/2026</a:t>
             </a:fld>
             <a:endParaRPr lang="es-ES"/>
           </a:p>
@@ -457,7 +457,7 @@
           <a:p>
             <a:fld id="{1A8F9070-8861-4FBE-84D2-FE8E101678E2}" type="datetimeFigureOut">
               <a:rPr lang="es-ES" smtClean="0"/>
-              <a:t>10/06/2026</a:t>
+              <a:t>14/06/2026</a:t>
             </a:fld>
             <a:endParaRPr lang="es-ES"/>
           </a:p>
@@ -665,7 +665,7 @@
           <a:p>
             <a:fld id="{1A8F9070-8861-4FBE-84D2-FE8E101678E2}" type="datetimeFigureOut">
               <a:rPr lang="es-ES" smtClean="0"/>
-              <a:t>10/06/2026</a:t>
+              <a:t>14/06/2026</a:t>
             </a:fld>
             <a:endParaRPr lang="es-ES"/>
           </a:p>
@@ -863,7 +863,7 @@
           <a:p>
             <a:fld id="{1A8F9070-8861-4FBE-84D2-FE8E101678E2}" type="datetimeFigureOut">
               <a:rPr lang="es-ES" smtClean="0"/>
-              <a:t>10/06/2026</a:t>
+              <a:t>14/06/2026</a:t>
             </a:fld>
             <a:endParaRPr lang="es-ES"/>
           </a:p>
@@ -1138,7 +1138,7 @@
           <a:p>
             <a:fld id="{1A8F9070-8861-4FBE-84D2-FE8E101678E2}" type="datetimeFigureOut">
               <a:rPr lang="es-ES" smtClean="0"/>
-              <a:t>10/06/2026</a:t>
+              <a:t>14/06/2026</a:t>
             </a:fld>
             <a:endParaRPr lang="es-ES"/>
           </a:p>
@@ -1403,7 +1403,7 @@
           <a:p>
             <a:fld id="{1A8F9070-8861-4FBE-84D2-FE8E101678E2}" type="datetimeFigureOut">
               <a:rPr lang="es-ES" smtClean="0"/>
-              <a:t>10/06/2026</a:t>
+              <a:t>14/06/2026</a:t>
             </a:fld>
             <a:endParaRPr lang="es-ES"/>
           </a:p>
@@ -1815,7 +1815,7 @@
           <a:p>
             <a:fld id="{1A8F9070-8861-4FBE-84D2-FE8E101678E2}" type="datetimeFigureOut">
               <a:rPr lang="es-ES" smtClean="0"/>
-              <a:t>10/06/2026</a:t>
+              <a:t>14/06/2026</a:t>
             </a:fld>
             <a:endParaRPr lang="es-ES"/>
           </a:p>
@@ -1956,7 +1956,7 @@
           <a:p>
             <a:fld id="{1A8F9070-8861-4FBE-84D2-FE8E101678E2}" type="datetimeFigureOut">
               <a:rPr lang="es-ES" smtClean="0"/>
-              <a:t>10/06/2026</a:t>
+              <a:t>14/06/2026</a:t>
             </a:fld>
             <a:endParaRPr lang="es-ES"/>
           </a:p>
@@ -2069,7 +2069,7 @@
           <a:p>
             <a:fld id="{1A8F9070-8861-4FBE-84D2-FE8E101678E2}" type="datetimeFigureOut">
               <a:rPr lang="es-ES" smtClean="0"/>
-              <a:t>10/06/2026</a:t>
+              <a:t>14/06/2026</a:t>
             </a:fld>
             <a:endParaRPr lang="es-ES"/>
           </a:p>
@@ -2380,7 +2380,7 @@
           <a:p>
             <a:fld id="{1A8F9070-8861-4FBE-84D2-FE8E101678E2}" type="datetimeFigureOut">
               <a:rPr lang="es-ES" smtClean="0"/>
-              <a:t>10/06/2026</a:t>
+              <a:t>14/06/2026</a:t>
             </a:fld>
             <a:endParaRPr lang="es-ES"/>
           </a:p>
@@ -2668,7 +2668,7 @@
           <a:p>
             <a:fld id="{1A8F9070-8861-4FBE-84D2-FE8E101678E2}" type="datetimeFigureOut">
               <a:rPr lang="es-ES" smtClean="0"/>
-              <a:t>10/06/2026</a:t>
+              <a:t>14/06/2026</a:t>
             </a:fld>
             <a:endParaRPr lang="es-ES"/>
           </a:p>
@@ -2909,7 +2909,7 @@
           <a:p>
             <a:fld id="{1A8F9070-8861-4FBE-84D2-FE8E101678E2}" type="datetimeFigureOut">
               <a:rPr lang="es-ES" smtClean="0"/>
-              <a:t>10/06/2026</a:t>
+              <a:t>14/06/2026</a:t>
             </a:fld>
             <a:endParaRPr lang="es-ES"/>
           </a:p>
@@ -5112,6 +5112,88 @@
           </p:txBody>
         </p:sp>
       </p:grpSp>
+      <p:grpSp>
+        <p:nvGrpSpPr>
+          <p:cNvPr id="16" name="Grupo 15">
+            <a:extLst>
+              <a:ext uri="{FF2B5EF4-FFF2-40B4-BE49-F238E27FC236}">
+                <a16:creationId xmlns:a16="http://schemas.microsoft.com/office/drawing/2014/main" id="{B130D172-D0AD-7271-D1F6-6B3667AA9CFE}"/>
+              </a:ext>
+            </a:extLst>
+          </p:cNvPr>
+          <p:cNvGrpSpPr/>
+          <p:nvPr/>
+        </p:nvGrpSpPr>
+        <p:grpSpPr>
+          <a:xfrm>
+            <a:off x="2053406" y="3764127"/>
+            <a:ext cx="6188797" cy="3216252"/>
+            <a:chOff x="356738" y="2498748"/>
+            <a:chExt cx="6188797" cy="3216252"/>
+          </a:xfrm>
+        </p:grpSpPr>
+        <p:pic>
+          <p:nvPicPr>
+            <p:cNvPr id="7" name="Imagen 6">
+              <a:extLst>
+                <a:ext uri="{FF2B5EF4-FFF2-40B4-BE49-F238E27FC236}">
+                  <a16:creationId xmlns:a16="http://schemas.microsoft.com/office/drawing/2014/main" id="{96E2204C-B634-23B5-9038-63B4474ED89A}"/>
+                </a:ext>
+              </a:extLst>
+            </p:cNvPr>
+            <p:cNvPicPr>
+              <a:picLocks noChangeAspect="1"/>
+            </p:cNvPicPr>
+            <p:nvPr/>
+          </p:nvPicPr>
+          <p:blipFill>
+            <a:blip r:embed="rId8"/>
+            <a:srcRect r="48685"/>
+            <a:stretch>
+              <a:fillRect/>
+            </a:stretch>
+          </p:blipFill>
+          <p:spPr>
+            <a:xfrm>
+              <a:off x="356738" y="2498748"/>
+              <a:ext cx="3548369" cy="3216252"/>
+            </a:xfrm>
+            <a:prstGeom prst="rect">
+              <a:avLst/>
+            </a:prstGeom>
+          </p:spPr>
+        </p:pic>
+        <p:pic>
+          <p:nvPicPr>
+            <p:cNvPr id="3" name="Imagen 2">
+              <a:extLst>
+                <a:ext uri="{FF2B5EF4-FFF2-40B4-BE49-F238E27FC236}">
+                  <a16:creationId xmlns:a16="http://schemas.microsoft.com/office/drawing/2014/main" id="{904D4558-7101-D9A4-74F0-C5D80BEC7803}"/>
+                </a:ext>
+              </a:extLst>
+            </p:cNvPr>
+            <p:cNvPicPr>
+              <a:picLocks noChangeAspect="1"/>
+            </p:cNvPicPr>
+            <p:nvPr/>
+          </p:nvPicPr>
+          <p:blipFill>
+            <a:blip r:embed="rId9"/>
+            <a:stretch>
+              <a:fillRect/>
+            </a:stretch>
+          </p:blipFill>
+          <p:spPr>
+            <a:xfrm>
+              <a:off x="3733284" y="2606040"/>
+              <a:ext cx="2812251" cy="2594635"/>
+            </a:xfrm>
+            <a:prstGeom prst="rect">
+              <a:avLst/>
+            </a:prstGeom>
+          </p:spPr>
+        </p:pic>
+      </p:grpSp>
     </p:spTree>
     <p:extLst>
       <p:ext uri="{BB962C8B-B14F-4D97-AF65-F5344CB8AC3E}">

</xml_diff>

<commit_message>
Add new presentation file for graphical data analysis
</commit_message>
<xml_diff>
--- a/Presentación1.pptx
+++ b/Presentación1.pptx
@@ -259,7 +259,7 @@
           <a:p>
             <a:fld id="{1A8F9070-8861-4FBE-84D2-FE8E101678E2}" type="datetimeFigureOut">
               <a:rPr lang="es-ES" smtClean="0"/>
-              <a:t>14/06/2026</a:t>
+              <a:t>15/06/2026</a:t>
             </a:fld>
             <a:endParaRPr lang="es-ES"/>
           </a:p>
@@ -457,7 +457,7 @@
           <a:p>
             <a:fld id="{1A8F9070-8861-4FBE-84D2-FE8E101678E2}" type="datetimeFigureOut">
               <a:rPr lang="es-ES" smtClean="0"/>
-              <a:t>14/06/2026</a:t>
+              <a:t>15/06/2026</a:t>
             </a:fld>
             <a:endParaRPr lang="es-ES"/>
           </a:p>
@@ -665,7 +665,7 @@
           <a:p>
             <a:fld id="{1A8F9070-8861-4FBE-84D2-FE8E101678E2}" type="datetimeFigureOut">
               <a:rPr lang="es-ES" smtClean="0"/>
-              <a:t>14/06/2026</a:t>
+              <a:t>15/06/2026</a:t>
             </a:fld>
             <a:endParaRPr lang="es-ES"/>
           </a:p>
@@ -863,7 +863,7 @@
           <a:p>
             <a:fld id="{1A8F9070-8861-4FBE-84D2-FE8E101678E2}" type="datetimeFigureOut">
               <a:rPr lang="es-ES" smtClean="0"/>
-              <a:t>14/06/2026</a:t>
+              <a:t>15/06/2026</a:t>
             </a:fld>
             <a:endParaRPr lang="es-ES"/>
           </a:p>
@@ -1138,7 +1138,7 @@
           <a:p>
             <a:fld id="{1A8F9070-8861-4FBE-84D2-FE8E101678E2}" type="datetimeFigureOut">
               <a:rPr lang="es-ES" smtClean="0"/>
-              <a:t>14/06/2026</a:t>
+              <a:t>15/06/2026</a:t>
             </a:fld>
             <a:endParaRPr lang="es-ES"/>
           </a:p>
@@ -1403,7 +1403,7 @@
           <a:p>
             <a:fld id="{1A8F9070-8861-4FBE-84D2-FE8E101678E2}" type="datetimeFigureOut">
               <a:rPr lang="es-ES" smtClean="0"/>
-              <a:t>14/06/2026</a:t>
+              <a:t>15/06/2026</a:t>
             </a:fld>
             <a:endParaRPr lang="es-ES"/>
           </a:p>
@@ -1815,7 +1815,7 @@
           <a:p>
             <a:fld id="{1A8F9070-8861-4FBE-84D2-FE8E101678E2}" type="datetimeFigureOut">
               <a:rPr lang="es-ES" smtClean="0"/>
-              <a:t>14/06/2026</a:t>
+              <a:t>15/06/2026</a:t>
             </a:fld>
             <a:endParaRPr lang="es-ES"/>
           </a:p>
@@ -1956,7 +1956,7 @@
           <a:p>
             <a:fld id="{1A8F9070-8861-4FBE-84D2-FE8E101678E2}" type="datetimeFigureOut">
               <a:rPr lang="es-ES" smtClean="0"/>
-              <a:t>14/06/2026</a:t>
+              <a:t>15/06/2026</a:t>
             </a:fld>
             <a:endParaRPr lang="es-ES"/>
           </a:p>
@@ -2069,7 +2069,7 @@
           <a:p>
             <a:fld id="{1A8F9070-8861-4FBE-84D2-FE8E101678E2}" type="datetimeFigureOut">
               <a:rPr lang="es-ES" smtClean="0"/>
-              <a:t>14/06/2026</a:t>
+              <a:t>15/06/2026</a:t>
             </a:fld>
             <a:endParaRPr lang="es-ES"/>
           </a:p>
@@ -2380,7 +2380,7 @@
           <a:p>
             <a:fld id="{1A8F9070-8861-4FBE-84D2-FE8E101678E2}" type="datetimeFigureOut">
               <a:rPr lang="es-ES" smtClean="0"/>
-              <a:t>14/06/2026</a:t>
+              <a:t>15/06/2026</a:t>
             </a:fld>
             <a:endParaRPr lang="es-ES"/>
           </a:p>
@@ -2668,7 +2668,7 @@
           <a:p>
             <a:fld id="{1A8F9070-8861-4FBE-84D2-FE8E101678E2}" type="datetimeFigureOut">
               <a:rPr lang="es-ES" smtClean="0"/>
-              <a:t>14/06/2026</a:t>
+              <a:t>15/06/2026</a:t>
             </a:fld>
             <a:endParaRPr lang="es-ES"/>
           </a:p>
@@ -2909,7 +2909,7 @@
           <a:p>
             <a:fld id="{1A8F9070-8861-4FBE-84D2-FE8E101678E2}" type="datetimeFigureOut">
               <a:rPr lang="es-ES" smtClean="0"/>
-              <a:t>14/06/2026</a:t>
+              <a:t>15/06/2026</a:t>
             </a:fld>
             <a:endParaRPr lang="es-ES"/>
           </a:p>
@@ -3340,7 +3340,7 @@
         </p:nvGrpSpPr>
         <p:grpSpPr>
           <a:xfrm>
-            <a:off x="4267265" y="1774068"/>
+            <a:off x="6477065" y="0"/>
             <a:ext cx="5105715" cy="2245438"/>
             <a:chOff x="4267265" y="1774068"/>
             <a:chExt cx="5105715" cy="2245438"/>
@@ -5114,10 +5114,10 @@
       </p:grpSp>
       <p:grpSp>
         <p:nvGrpSpPr>
-          <p:cNvPr id="16" name="Grupo 15">
-            <a:extLst>
-              <a:ext uri="{FF2B5EF4-FFF2-40B4-BE49-F238E27FC236}">
-                <a16:creationId xmlns:a16="http://schemas.microsoft.com/office/drawing/2014/main" id="{B130D172-D0AD-7271-D1F6-6B3667AA9CFE}"/>
+          <p:cNvPr id="28" name="Grupo 27">
+            <a:extLst>
+              <a:ext uri="{FF2B5EF4-FFF2-40B4-BE49-F238E27FC236}">
+                <a16:creationId xmlns:a16="http://schemas.microsoft.com/office/drawing/2014/main" id="{6D190083-F137-3F2D-EEC3-B0643669BD63}"/>
               </a:ext>
             </a:extLst>
           </p:cNvPr>
@@ -5126,18 +5126,243 @@
         </p:nvGrpSpPr>
         <p:grpSpPr>
           <a:xfrm>
-            <a:off x="2053406" y="3764127"/>
-            <a:ext cx="6188797" cy="3216252"/>
-            <a:chOff x="356738" y="2498748"/>
-            <a:chExt cx="6188797" cy="3216252"/>
+            <a:off x="1843680" y="1871389"/>
+            <a:ext cx="5440908" cy="2594635"/>
+            <a:chOff x="1843680" y="1871389"/>
+            <a:chExt cx="5440908" cy="2594635"/>
           </a:xfrm>
         </p:grpSpPr>
+        <p:grpSp>
+          <p:nvGrpSpPr>
+            <p:cNvPr id="23" name="Grupo 22">
+              <a:extLst>
+                <a:ext uri="{FF2B5EF4-FFF2-40B4-BE49-F238E27FC236}">
+                  <a16:creationId xmlns:a16="http://schemas.microsoft.com/office/drawing/2014/main" id="{F7777BB6-BE79-C613-DE91-BAEC6B2DCE88}"/>
+                </a:ext>
+              </a:extLst>
+            </p:cNvPr>
+            <p:cNvGrpSpPr/>
+            <p:nvPr/>
+          </p:nvGrpSpPr>
+          <p:grpSpPr>
+            <a:xfrm>
+              <a:off x="1843680" y="1871389"/>
+              <a:ext cx="5440908" cy="2594635"/>
+              <a:chOff x="1843680" y="1871389"/>
+              <a:chExt cx="5440908" cy="2594635"/>
+            </a:xfrm>
+          </p:grpSpPr>
+          <p:grpSp>
+            <p:nvGrpSpPr>
+              <p:cNvPr id="2" name="Grupo 1">
+                <a:extLst>
+                  <a:ext uri="{FF2B5EF4-FFF2-40B4-BE49-F238E27FC236}">
+                    <a16:creationId xmlns:a16="http://schemas.microsoft.com/office/drawing/2014/main" id="{3CB3ABB7-FAA7-3E23-CEE2-E4348C04357C}"/>
+                  </a:ext>
+                </a:extLst>
+              </p:cNvPr>
+              <p:cNvGrpSpPr/>
+              <p:nvPr/>
+            </p:nvGrpSpPr>
+            <p:grpSpPr>
+              <a:xfrm>
+                <a:off x="1843680" y="1871389"/>
+                <a:ext cx="5440908" cy="2594635"/>
+                <a:chOff x="1104627" y="2606040"/>
+                <a:chExt cx="5440908" cy="2594635"/>
+              </a:xfrm>
+            </p:grpSpPr>
+            <p:pic>
+              <p:nvPicPr>
+                <p:cNvPr id="4" name="Imagen 3">
+                  <a:extLst>
+                    <a:ext uri="{FF2B5EF4-FFF2-40B4-BE49-F238E27FC236}">
+                      <a16:creationId xmlns:a16="http://schemas.microsoft.com/office/drawing/2014/main" id="{113172DE-FE03-368C-89AB-02CC438A138C}"/>
+                    </a:ext>
+                  </a:extLst>
+                </p:cNvPr>
+                <p:cNvPicPr>
+                  <a:picLocks noChangeAspect="1"/>
+                </p:cNvPicPr>
+                <p:nvPr/>
+              </p:nvPicPr>
+              <p:blipFill>
+                <a:blip r:embed="rId8"/>
+                <a:srcRect l="10816" t="3336" r="48685" b="15992"/>
+                <a:stretch>
+                  <a:fillRect/>
+                </a:stretch>
+              </p:blipFill>
+              <p:spPr>
+                <a:xfrm>
+                  <a:off x="1104627" y="2606040"/>
+                  <a:ext cx="2800480" cy="2594635"/>
+                </a:xfrm>
+                <a:prstGeom prst="rect">
+                  <a:avLst/>
+                </a:prstGeom>
+              </p:spPr>
+            </p:pic>
+            <p:pic>
+              <p:nvPicPr>
+                <p:cNvPr id="17" name="Imagen 16">
+                  <a:extLst>
+                    <a:ext uri="{FF2B5EF4-FFF2-40B4-BE49-F238E27FC236}">
+                      <a16:creationId xmlns:a16="http://schemas.microsoft.com/office/drawing/2014/main" id="{0BEC27E7-C732-B82D-C16D-F2C1DA986150}"/>
+                    </a:ext>
+                  </a:extLst>
+                </p:cNvPr>
+                <p:cNvPicPr>
+                  <a:picLocks noChangeAspect="1"/>
+                </p:cNvPicPr>
+                <p:nvPr/>
+              </p:nvPicPr>
+              <p:blipFill>
+                <a:blip r:embed="rId9"/>
+                <a:stretch>
+                  <a:fillRect/>
+                </a:stretch>
+              </p:blipFill>
+              <p:spPr>
+                <a:xfrm>
+                  <a:off x="3733284" y="2606040"/>
+                  <a:ext cx="2812251" cy="2594635"/>
+                </a:xfrm>
+                <a:prstGeom prst="rect">
+                  <a:avLst/>
+                </a:prstGeom>
+              </p:spPr>
+            </p:pic>
+          </p:grpSp>
+          <p:sp>
+            <p:nvSpPr>
+              <p:cNvPr id="20" name="Rectángulo 19">
+                <a:extLst>
+                  <a:ext uri="{FF2B5EF4-FFF2-40B4-BE49-F238E27FC236}">
+                    <a16:creationId xmlns:a16="http://schemas.microsoft.com/office/drawing/2014/main" id="{B26467CF-979E-FEB8-8C66-05DFB3B6FA4D}"/>
+                  </a:ext>
+                </a:extLst>
+              </p:cNvPr>
+              <p:cNvSpPr/>
+              <p:nvPr/>
+            </p:nvSpPr>
+            <p:spPr>
+              <a:xfrm>
+                <a:off x="3885283" y="1911860"/>
+                <a:ext cx="424084" cy="256030"/>
+              </a:xfrm>
+              <a:prstGeom prst="rect">
+                <a:avLst/>
+              </a:prstGeom>
+              <a:solidFill>
+                <a:srgbClr val="FFFFFF">
+                  <a:alpha val="80000"/>
+                </a:srgbClr>
+              </a:solidFill>
+              <a:ln>
+                <a:noFill/>
+              </a:ln>
+            </p:spPr>
+            <p:style>
+              <a:lnRef idx="2">
+                <a:schemeClr val="accent1">
+                  <a:shade val="15000"/>
+                </a:schemeClr>
+              </a:lnRef>
+              <a:fillRef idx="1">
+                <a:schemeClr val="accent1"/>
+              </a:fillRef>
+              <a:effectRef idx="0">
+                <a:schemeClr val="accent1"/>
+              </a:effectRef>
+              <a:fontRef idx="minor">
+                <a:schemeClr val="lt1"/>
+              </a:fontRef>
+            </p:style>
+            <p:txBody>
+              <a:bodyPr rtlCol="0" anchor="ctr"/>
+              <a:lstStyle/>
+              <a:p>
+                <a:pPr algn="ctr"/>
+                <a:r>
+                  <a:rPr lang="es-ES" sz="2000" b="1" dirty="0">
+                    <a:solidFill>
+                      <a:schemeClr val="tx1"/>
+                    </a:solidFill>
+                  </a:rPr>
+                  <a:t>A)</a:t>
+                </a:r>
+              </a:p>
+            </p:txBody>
+          </p:sp>
+          <p:sp>
+            <p:nvSpPr>
+              <p:cNvPr id="21" name="Rectángulo 20">
+                <a:extLst>
+                  <a:ext uri="{FF2B5EF4-FFF2-40B4-BE49-F238E27FC236}">
+                    <a16:creationId xmlns:a16="http://schemas.microsoft.com/office/drawing/2014/main" id="{8F846C27-0E6A-A818-44D0-43B8EF73A40A}"/>
+                  </a:ext>
+                </a:extLst>
+              </p:cNvPr>
+              <p:cNvSpPr/>
+              <p:nvPr/>
+            </p:nvSpPr>
+            <p:spPr>
+              <a:xfrm>
+                <a:off x="6779019" y="1913592"/>
+                <a:ext cx="424084" cy="256030"/>
+              </a:xfrm>
+              <a:prstGeom prst="rect">
+                <a:avLst/>
+              </a:prstGeom>
+              <a:solidFill>
+                <a:srgbClr val="FFFFFF">
+                  <a:alpha val="80000"/>
+                </a:srgbClr>
+              </a:solidFill>
+              <a:ln>
+                <a:noFill/>
+              </a:ln>
+            </p:spPr>
+            <p:style>
+              <a:lnRef idx="2">
+                <a:schemeClr val="accent1">
+                  <a:shade val="15000"/>
+                </a:schemeClr>
+              </a:lnRef>
+              <a:fillRef idx="1">
+                <a:schemeClr val="accent1"/>
+              </a:fillRef>
+              <a:effectRef idx="0">
+                <a:schemeClr val="accent1"/>
+              </a:effectRef>
+              <a:fontRef idx="minor">
+                <a:schemeClr val="lt1"/>
+              </a:fontRef>
+            </p:style>
+            <p:txBody>
+              <a:bodyPr rtlCol="0" anchor="ctr"/>
+              <a:lstStyle/>
+              <a:p>
+                <a:pPr algn="ctr"/>
+                <a:r>
+                  <a:rPr lang="es-ES" sz="2000" b="1" dirty="0">
+                    <a:solidFill>
+                      <a:schemeClr val="tx1"/>
+                    </a:solidFill>
+                  </a:rPr>
+                  <a:t>B)</a:t>
+                </a:r>
+              </a:p>
+            </p:txBody>
+          </p:sp>
+        </p:grpSp>
         <p:pic>
           <p:nvPicPr>
-            <p:cNvPr id="7" name="Imagen 6">
+            <p:cNvPr id="27" name="Imagen 26">
               <a:extLst>
                 <a:ext uri="{FF2B5EF4-FFF2-40B4-BE49-F238E27FC236}">
-                  <a16:creationId xmlns:a16="http://schemas.microsoft.com/office/drawing/2014/main" id="{96E2204C-B634-23B5-9038-63B4474ED89A}"/>
+                  <a16:creationId xmlns:a16="http://schemas.microsoft.com/office/drawing/2014/main" id="{5E7AC97A-BE7E-3900-31F0-489A6F2EA9D8}"/>
                 </a:ext>
               </a:extLst>
             </p:cNvPr>
@@ -5147,46 +5372,15 @@
             <p:nvPr/>
           </p:nvPicPr>
           <p:blipFill>
-            <a:blip r:embed="rId8"/>
-            <a:srcRect r="48685"/>
+            <a:blip r:embed="rId10"/>
             <a:stretch>
               <a:fillRect/>
             </a:stretch>
           </p:blipFill>
           <p:spPr>
             <a:xfrm>
-              <a:off x="356738" y="2498748"/>
-              <a:ext cx="3548369" cy="3216252"/>
-            </a:xfrm>
-            <a:prstGeom prst="rect">
-              <a:avLst/>
-            </a:prstGeom>
-          </p:spPr>
-        </p:pic>
-        <p:pic>
-          <p:nvPicPr>
-            <p:cNvPr id="3" name="Imagen 2">
-              <a:extLst>
-                <a:ext uri="{FF2B5EF4-FFF2-40B4-BE49-F238E27FC236}">
-                  <a16:creationId xmlns:a16="http://schemas.microsoft.com/office/drawing/2014/main" id="{904D4558-7101-D9A4-74F0-C5D80BEC7803}"/>
-                </a:ext>
-              </a:extLst>
-            </p:cNvPr>
-            <p:cNvPicPr>
-              <a:picLocks noChangeAspect="1"/>
-            </p:cNvPicPr>
-            <p:nvPr/>
-          </p:nvPicPr>
-          <p:blipFill>
-            <a:blip r:embed="rId9"/>
-            <a:stretch>
-              <a:fillRect/>
-            </a:stretch>
-          </p:blipFill>
-          <p:spPr>
-            <a:xfrm>
-              <a:off x="3733284" y="2606040"/>
-              <a:ext cx="2812251" cy="2594635"/>
+              <a:off x="1887523" y="2245438"/>
+              <a:ext cx="705885" cy="799387"/>
             </a:xfrm>
             <a:prstGeom prst="rect">
               <a:avLst/>

</xml_diff>